<commit_message>
style: update Asian student illustration on cover and 3-card graphical diagram for SLC 3-level analysis on slide 5
</commit_message>
<xml_diff>
--- a/output/slides.pptx
+++ b/output/slides.pptx
@@ -4082,7 +4082,7 @@
         <p:spPr>
           <a:xfrm>
             <a:off x="731520" y="1645920"/>
-            <a:ext cx="10728655" cy="4572000"/>
+            <a:ext cx="5943600" cy="4572000"/>
           </a:xfrm>
           <a:prstGeom prst="rect">
             <a:avLst/>
@@ -4177,6 +4177,30 @@
           </a:p>
         </p:txBody>
       </p:sp>
+      <p:pic>
+        <p:nvPicPr>
+          <p:cNvPr id="4" name="Picture 3" descr="slide_5.png"/>
+          <p:cNvPicPr>
+            <a:picLocks noChangeAspect="1"/>
+          </p:cNvPicPr>
+          <p:nvPr/>
+        </p:nvPicPr>
+        <p:blipFill>
+          <a:blip r:embed="rId2"/>
+          <a:stretch>
+            <a:fillRect/>
+          </a:stretch>
+        </p:blipFill>
+        <p:spPr>
+          <a:xfrm>
+            <a:off x="7589520" y="1828800"/>
+            <a:ext cx="3840480" cy="3840480"/>
+          </a:xfrm>
+          <a:prstGeom prst="rect">
+            <a:avLst/>
+          </a:prstGeom>
+        </p:spPr>
+      </p:pic>
     </p:spTree>
   </p:cSld>
   <p:clrMapOvr>

</xml_diff>

<commit_message>
fix: remove image on slide 5 and delete redundant slides 10-11
</commit_message>
<xml_diff>
--- a/output/slides.pptx
+++ b/output/slides.pptx
@@ -14,9 +14,6 @@
     <p:sldId id="262" r:id="rId13"/>
     <p:sldId id="263" r:id="rId14"/>
     <p:sldId id="264" r:id="rId15"/>
-    <p:sldId id="265" r:id="rId16"/>
-    <p:sldId id="266" r:id="rId17"/>
-    <p:sldId id="267" r:id="rId18"/>
   </p:sldIdLst>
   <p:sldSz cx="12191695" cy="6858000" type="screen4x3"/>
   <p:notesSz cx="6858000" cy="9144000"/>
@@ -3199,472 +3196,6 @@
 </p:sld>
 </file>
 
-<file path=ppt/slides/slide10.xml><?xml version="1.0" encoding="utf-8"?>
-<p:sld xmlns:a="http://schemas.openxmlformats.org/drawingml/2006/main" xmlns:p="http://schemas.openxmlformats.org/presentationml/2006/main" xmlns:r="http://schemas.openxmlformats.org/officeDocument/2006/relationships">
-  <p:cSld>
-    <p:bg>
-      <p:bgPr>
-        <a:solidFill>
-          <a:srgbClr val="E6F0FA"/>
-        </a:solidFill>
-        <a:effectLst/>
-      </p:bgPr>
-    </p:bg>
-    <p:spTree>
-      <p:nvGrpSpPr>
-        <p:cNvPr id="1" name=""/>
-        <p:cNvGrpSpPr/>
-        <p:nvPr/>
-      </p:nvGrpSpPr>
-      <p:grpSpPr/>
-      <p:sp>
-        <p:nvSpPr>
-          <p:cNvPr id="2" name="TextBox 1"/>
-          <p:cNvSpPr txBox="1"/>
-          <p:nvPr/>
-        </p:nvSpPr>
-        <p:spPr>
-          <a:xfrm>
-            <a:off x="731520" y="548640"/>
-            <a:ext cx="10728655" cy="914400"/>
-          </a:xfrm>
-          <a:prstGeom prst="rect">
-            <a:avLst/>
-          </a:prstGeom>
-          <a:noFill/>
-        </p:spPr>
-        <p:txBody>
-          <a:bodyPr wrap="square">
-            <a:spAutoFit/>
-          </a:bodyPr>
-          <a:lstStyle/>
-          <a:p>
-            <a:pPr>
-              <a:defRPr sz="3200" b="1">
-                <a:solidFill>
-                  <a:srgbClr val="0A2850"/>
-                </a:solidFill>
-                <a:latin typeface="Microsoft JhengHei"/>
-              </a:defRPr>
-            </a:pPr>
-            <a:r>
-              <a:t>三、 簡報架構規劃與頁面設計 (16:9 Slide Blueprint) (I)</a:t>
-            </a:r>
-          </a:p>
-        </p:txBody>
-      </p:sp>
-      <p:sp>
-        <p:nvSpPr>
-          <p:cNvPr id="3" name="TextBox 2"/>
-          <p:cNvSpPr txBox="1"/>
-          <p:nvPr/>
-        </p:nvSpPr>
-        <p:spPr>
-          <a:xfrm>
-            <a:off x="731520" y="1645920"/>
-            <a:ext cx="10728655" cy="4572000"/>
-          </a:xfrm>
-          <a:prstGeom prst="rect">
-            <a:avLst/>
-          </a:prstGeom>
-          <a:noFill/>
-        </p:spPr>
-        <p:txBody>
-          <a:bodyPr wrap="square">
-            <a:spAutoFit/>
-          </a:bodyPr>
-          <a:lstStyle/>
-          <a:p/>
-          <a:p>
-            <a:pPr>
-              <a:spcAft>
-                <a:spcPts val="1000"/>
-              </a:spcAft>
-              <a:defRPr sz="2000">
-                <a:solidFill>
-                  <a:srgbClr val="1E3250"/>
-                </a:solidFill>
-                <a:latin typeface="Microsoft JhengHei"/>
-              </a:defRPr>
-            </a:pPr>
-            <a:r>
-              <a:t>• Slide 1: 封面 - 學習共同體公開課課例研究：五年級社會「儲蓄方案大比拼」</a:t>
-            </a:r>
-          </a:p>
-          <a:p>
-            <a:pPr>
-              <a:spcAft>
-                <a:spcPts val="1000"/>
-              </a:spcAft>
-              <a:defRPr sz="2000">
-                <a:solidFill>
-                  <a:srgbClr val="1E3250"/>
-                </a:solidFill>
-                <a:latin typeface="Microsoft JhengHei"/>
-              </a:defRPr>
-            </a:pPr>
-            <a:r>
-              <a:t>• Slide 2: 課例基本資訊與教學脈絡</a:t>
-            </a:r>
-          </a:p>
-          <a:p>
-            <a:pPr>
-              <a:spcAft>
-                <a:spcPts val="1000"/>
-              </a:spcAft>
-              <a:defRPr sz="2000">
-                <a:solidFill>
-                  <a:srgbClr val="1E3250"/>
-                </a:solidFill>
-                <a:latin typeface="Microsoft JhengHei"/>
-              </a:defRPr>
-            </a:pPr>
-            <a:r>
-              <a:t>• Slide 3: 情境喚起 - 人生各階段的理財目標</a:t>
-            </a:r>
-          </a:p>
-          <a:p>
-            <a:pPr>
-              <a:spcAft>
-                <a:spcPts val="1000"/>
-              </a:spcAft>
-              <a:defRPr sz="2000">
-                <a:solidFill>
-                  <a:srgbClr val="1E3250"/>
-                </a:solidFill>
-                <a:latin typeface="Microsoft JhengHei"/>
-              </a:defRPr>
-            </a:pPr>
-            <a:r>
-              <a:t>• Slide 4: 核心概念 - 收入、支出與儲蓄的數學關係</a:t>
-            </a:r>
-          </a:p>
-          <a:p>
-            <a:pPr>
-              <a:spcAft>
-                <a:spcPts val="1000"/>
-              </a:spcAft>
-              <a:defRPr sz="2000">
-                <a:solidFill>
-                  <a:srgbClr val="1E3250"/>
-                </a:solidFill>
-                <a:latin typeface="Microsoft JhengHei"/>
-              </a:defRPr>
-            </a:pPr>
-            <a:r>
-              <a:t>• Slide 5: 任務設計 - 方案一 vs 方案二（先消費 vs 先儲蓄）</a:t>
-            </a:r>
-          </a:p>
-        </p:txBody>
-      </p:sp>
-    </p:spTree>
-  </p:cSld>
-  <p:clrMapOvr>
-    <a:masterClrMapping/>
-  </p:clrMapOvr>
-</p:sld>
-</file>
-
-<file path=ppt/slides/slide11.xml><?xml version="1.0" encoding="utf-8"?>
-<p:sld xmlns:a="http://schemas.openxmlformats.org/drawingml/2006/main" xmlns:p="http://schemas.openxmlformats.org/presentationml/2006/main" xmlns:r="http://schemas.openxmlformats.org/officeDocument/2006/relationships">
-  <p:cSld>
-    <p:bg>
-      <p:bgPr>
-        <a:solidFill>
-          <a:srgbClr val="E6F0FA"/>
-        </a:solidFill>
-        <a:effectLst/>
-      </p:bgPr>
-    </p:bg>
-    <p:spTree>
-      <p:nvGrpSpPr>
-        <p:cNvPr id="1" name=""/>
-        <p:cNvGrpSpPr/>
-        <p:nvPr/>
-      </p:nvGrpSpPr>
-      <p:grpSpPr/>
-      <p:sp>
-        <p:nvSpPr>
-          <p:cNvPr id="2" name="TextBox 1"/>
-          <p:cNvSpPr txBox="1"/>
-          <p:nvPr/>
-        </p:nvSpPr>
-        <p:spPr>
-          <a:xfrm>
-            <a:off x="731520" y="548640"/>
-            <a:ext cx="10728655" cy="914400"/>
-          </a:xfrm>
-          <a:prstGeom prst="rect">
-            <a:avLst/>
-          </a:prstGeom>
-          <a:noFill/>
-        </p:spPr>
-        <p:txBody>
-          <a:bodyPr wrap="square">
-            <a:spAutoFit/>
-          </a:bodyPr>
-          <a:lstStyle/>
-          <a:p>
-            <a:pPr>
-              <a:defRPr sz="3200" b="1">
-                <a:solidFill>
-                  <a:srgbClr val="0A2850"/>
-                </a:solidFill>
-                <a:latin typeface="Microsoft JhengHei"/>
-              </a:defRPr>
-            </a:pPr>
-            <a:r>
-              <a:t>三、 簡報架構規劃與頁面設計 (16:9 Slide Blueprint) (II)</a:t>
-            </a:r>
-          </a:p>
-        </p:txBody>
-      </p:sp>
-      <p:sp>
-        <p:nvSpPr>
-          <p:cNvPr id="3" name="TextBox 2"/>
-          <p:cNvSpPr txBox="1"/>
-          <p:nvPr/>
-        </p:nvSpPr>
-        <p:spPr>
-          <a:xfrm>
-            <a:off x="731520" y="1645920"/>
-            <a:ext cx="10728655" cy="4572000"/>
-          </a:xfrm>
-          <a:prstGeom prst="rect">
-            <a:avLst/>
-          </a:prstGeom>
-          <a:noFill/>
-        </p:spPr>
-        <p:txBody>
-          <a:bodyPr wrap="square">
-            <a:spAutoFit/>
-          </a:bodyPr>
-          <a:lstStyle/>
-          <a:p/>
-          <a:p>
-            <a:pPr>
-              <a:spcAft>
-                <a:spcPts val="1000"/>
-              </a:spcAft>
-              <a:defRPr sz="2000">
-                <a:solidFill>
-                  <a:srgbClr val="1E3250"/>
-                </a:solidFill>
-                <a:latin typeface="Microsoft JhengHei"/>
-              </a:defRPr>
-            </a:pPr>
-            <a:r>
-              <a:t>• Slide 6: 小組對話觀察 - 異質分組與傾聽輪流機制</a:t>
-            </a:r>
-          </a:p>
-          <a:p>
-            <a:pPr>
-              <a:spcAft>
-                <a:spcPts val="1000"/>
-              </a:spcAft>
-              <a:defRPr sz="2000">
-                <a:solidFill>
-                  <a:srgbClr val="1E3250"/>
-                </a:solidFill>
-                <a:latin typeface="Microsoft JhengHei"/>
-              </a:defRPr>
-            </a:pPr>
-            <a:r>
-              <a:t>• Slide 7: 學習者認知詮釋 - 延遲享樂與預算控制</a:t>
-            </a:r>
-          </a:p>
-          <a:p>
-            <a:pPr>
-              <a:spcAft>
-                <a:spcPts val="1000"/>
-              </a:spcAft>
-              <a:defRPr sz="2000">
-                <a:solidFill>
-                  <a:srgbClr val="1E3250"/>
-                </a:solidFill>
-                <a:latin typeface="Microsoft JhengHei"/>
-              </a:defRPr>
-            </a:pPr>
-            <a:r>
-              <a:t>• Slide 8: 教學亮點與 SLC 哲學反思</a:t>
-            </a:r>
-          </a:p>
-          <a:p>
-            <a:pPr>
-              <a:spcAft>
-                <a:spcPts val="1000"/>
-              </a:spcAft>
-              <a:defRPr sz="2000">
-                <a:solidFill>
-                  <a:srgbClr val="1E3250"/>
-                </a:solidFill>
-                <a:latin typeface="Microsoft JhengHei"/>
-              </a:defRPr>
-            </a:pPr>
-            <a:r>
-              <a:t>• Slide 9: 延伸思考 - 伸展跳躍與緊急預備金</a:t>
-            </a:r>
-          </a:p>
-          <a:p>
-            <a:pPr>
-              <a:spcAft>
-                <a:spcPts val="1000"/>
-              </a:spcAft>
-              <a:defRPr sz="2000">
-                <a:solidFill>
-                  <a:srgbClr val="1E3250"/>
-                </a:solidFill>
-                <a:latin typeface="Microsoft JhengHei"/>
-              </a:defRPr>
-            </a:pPr>
-            <a:r>
-              <a:t>• Slide 10: 結語與課例研究總結</a:t>
-            </a:r>
-          </a:p>
-        </p:txBody>
-      </p:sp>
-    </p:spTree>
-  </p:cSld>
-  <p:clrMapOvr>
-    <a:masterClrMapping/>
-  </p:clrMapOvr>
-</p:sld>
-</file>
-
-<file path=ppt/slides/slide12.xml><?xml version="1.0" encoding="utf-8"?>
-<p:sld xmlns:a="http://schemas.openxmlformats.org/drawingml/2006/main" xmlns:p="http://schemas.openxmlformats.org/presentationml/2006/main" xmlns:r="http://schemas.openxmlformats.org/officeDocument/2006/relationships">
-  <p:cSld>
-    <p:bg>
-      <p:bgPr>
-        <a:solidFill>
-          <a:srgbClr val="E6F0FA"/>
-        </a:solidFill>
-        <a:effectLst/>
-      </p:bgPr>
-    </p:bg>
-    <p:spTree>
-      <p:nvGrpSpPr>
-        <p:cNvPr id="1" name=""/>
-        <p:cNvGrpSpPr/>
-        <p:nvPr/>
-      </p:nvGrpSpPr>
-      <p:grpSpPr/>
-      <p:sp>
-        <p:nvSpPr>
-          <p:cNvPr id="2" name="TextBox 1"/>
-          <p:cNvSpPr txBox="1"/>
-          <p:nvPr/>
-        </p:nvSpPr>
-        <p:spPr>
-          <a:xfrm>
-            <a:off x="731520" y="548640"/>
-            <a:ext cx="10728655" cy="914400"/>
-          </a:xfrm>
-          <a:prstGeom prst="rect">
-            <a:avLst/>
-          </a:prstGeom>
-          <a:noFill/>
-        </p:spPr>
-        <p:txBody>
-          <a:bodyPr wrap="square">
-            <a:spAutoFit/>
-          </a:bodyPr>
-          <a:lstStyle/>
-          <a:p>
-            <a:pPr>
-              <a:defRPr sz="3200" b="1">
-                <a:solidFill>
-                  <a:srgbClr val="0A2850"/>
-                </a:solidFill>
-                <a:latin typeface="Microsoft JhengHei"/>
-              </a:defRPr>
-            </a:pPr>
-            <a:r>
-              <a:t>學習共同體課例探究與省思 - 專題討論 (12)</a:t>
-            </a:r>
-          </a:p>
-        </p:txBody>
-      </p:sp>
-      <p:sp>
-        <p:nvSpPr>
-          <p:cNvPr id="3" name="TextBox 2"/>
-          <p:cNvSpPr txBox="1"/>
-          <p:nvPr/>
-        </p:nvSpPr>
-        <p:spPr>
-          <a:xfrm>
-            <a:off x="731520" y="1645920"/>
-            <a:ext cx="10728655" cy="4572000"/>
-          </a:xfrm>
-          <a:prstGeom prst="rect">
-            <a:avLst/>
-          </a:prstGeom>
-          <a:noFill/>
-        </p:spPr>
-        <p:txBody>
-          <a:bodyPr wrap="square">
-            <a:spAutoFit/>
-          </a:bodyPr>
-          <a:lstStyle/>
-          <a:p/>
-          <a:p>
-            <a:pPr>
-              <a:spcAft>
-                <a:spcPts val="1000"/>
-              </a:spcAft>
-              <a:defRPr sz="2400">
-                <a:solidFill>
-                  <a:srgbClr val="1E3250"/>
-                </a:solidFill>
-                <a:latin typeface="Microsoft JhengHei"/>
-              </a:defRPr>
-            </a:pPr>
-            <a:r>
-              <a:t>• 聚焦微觀對話中的聆聽關係建立</a:t>
-            </a:r>
-          </a:p>
-          <a:p>
-            <a:pPr>
-              <a:spcAft>
-                <a:spcPts val="1000"/>
-              </a:spcAft>
-              <a:defRPr sz="2400">
-                <a:solidFill>
-                  <a:srgbClr val="1E3250"/>
-                </a:solidFill>
-                <a:latin typeface="Microsoft JhengHei"/>
-              </a:defRPr>
-            </a:pPr>
-            <a:r>
-              <a:t>• 探究協同合作與伸展跳躍學習的脈絡</a:t>
-            </a:r>
-          </a:p>
-          <a:p>
-            <a:pPr>
-              <a:spcAft>
-                <a:spcPts val="1000"/>
-              </a:spcAft>
-              <a:defRPr sz="2400">
-                <a:solidFill>
-                  <a:srgbClr val="1E3250"/>
-                </a:solidFill>
-                <a:latin typeface="Microsoft JhengHei"/>
-              </a:defRPr>
-            </a:pPr>
-            <a:r>
-              <a:t>• 思考教師如何建立公共溝通民主語言</a:t>
-            </a:r>
-          </a:p>
-        </p:txBody>
-      </p:sp>
-    </p:spTree>
-  </p:cSld>
-  <p:clrMapOvr>
-    <a:masterClrMapping/>
-  </p:clrMapOvr>
-</p:sld>
-</file>
-
 <file path=ppt/slides/slide2.xml><?xml version="1.0" encoding="utf-8"?>
 <p:sld xmlns:a="http://schemas.openxmlformats.org/drawingml/2006/main" xmlns:p="http://schemas.openxmlformats.org/presentationml/2006/main" xmlns:r="http://schemas.openxmlformats.org/officeDocument/2006/relationships">
   <p:cSld>
@@ -4082,7 +3613,7 @@
         <p:spPr>
           <a:xfrm>
             <a:off x="731520" y="1645920"/>
-            <a:ext cx="5943600" cy="4572000"/>
+            <a:ext cx="10728655" cy="4572000"/>
           </a:xfrm>
           <a:prstGeom prst="rect">
             <a:avLst/>
@@ -4177,30 +3708,6 @@
           </a:p>
         </p:txBody>
       </p:sp>
-      <p:pic>
-        <p:nvPicPr>
-          <p:cNvPr id="4" name="Picture 3" descr="slide_5.png"/>
-          <p:cNvPicPr>
-            <a:picLocks noChangeAspect="1"/>
-          </p:cNvPicPr>
-          <p:nvPr/>
-        </p:nvPicPr>
-        <p:blipFill>
-          <a:blip r:embed="rId2"/>
-          <a:stretch>
-            <a:fillRect/>
-          </a:stretch>
-        </p:blipFill>
-        <p:spPr>
-          <a:xfrm>
-            <a:off x="7589520" y="1828800"/>
-            <a:ext cx="3840480" cy="3840480"/>
-          </a:xfrm>
-          <a:prstGeom prst="rect">
-            <a:avLst/>
-          </a:prstGeom>
-        </p:spPr>
-      </p:pic>
     </p:spTree>
   </p:cSld>
   <p:clrMapOvr>

</xml_diff>

<commit_message>
style: enlarge body text font size on slide 2+ and correct text/bullet points on slides 3, 6, 8, 9
</commit_message>
<xml_diff>
--- a/output/slides.pptx
+++ b/output/slides.pptx
@@ -3245,6 +3245,7 @@
               </a:defRPr>
             </a:pPr>
             <a:r>
+              <a:rPr sz="3200"/>
               <a:t>一、 課例基本資訊與教學脈絡 (I)</a:t>
             </a:r>
           </a:p>
@@ -3285,6 +3286,7 @@
               </a:defRPr>
             </a:pPr>
             <a:r>
+              <a:rPr sz="2400"/>
               <a:t>• 授課教師：石諺群老師</a:t>
             </a:r>
           </a:p>
@@ -3301,6 +3303,7 @@
               </a:defRPr>
             </a:pPr>
             <a:r>
+              <a:rPr sz="2400"/>
               <a:t>• 授課年級/領域：國小五年級 社會領域</a:t>
             </a:r>
           </a:p>
@@ -3317,6 +3320,7 @@
               </a:defRPr>
             </a:pPr>
             <a:r>
+              <a:rPr sz="2400"/>
               <a:t>• 單元主題：儲蓄與理財（消費與儲蓄決策）</a:t>
             </a:r>
           </a:p>
@@ -3379,6 +3383,7 @@
               </a:defRPr>
             </a:pPr>
             <a:r>
+              <a:rPr sz="3200"/>
               <a:t>一、 課例基本資訊與教學脈絡 (II)</a:t>
             </a:r>
           </a:p>
@@ -3419,7 +3424,8 @@
               </a:defRPr>
             </a:pPr>
             <a:r>
-              <a:t>• 核心問題：如何透過「先存錢再消費」實現個人理理財目標？</a:t>
+              <a:rPr sz="2400"/>
+              <a:t>• 核心問題：如何透過「先存錢再消費」實現個人理財目標？</a:t>
             </a:r>
           </a:p>
           <a:p>
@@ -3435,6 +3441,7 @@
               </a:defRPr>
             </a:pPr>
             <a:r>
+              <a:rPr sz="2400"/>
               <a:t>• 小組學習機制：3-4人異質小組、對話協同學習、舉手發表與全班互學。</a:t>
             </a:r>
           </a:p>
@@ -3451,6 +3458,7 @@
               </a:defRPr>
             </a:pPr>
             <a:r>
+              <a:rPr sz="2400"/>
               <a:t>• </a:t>
             </a:r>
           </a:p>
@@ -3513,6 +3521,7 @@
               </a:defRPr>
             </a:pPr>
             <a:r>
+              <a:rPr sz="3200"/>
               <a:t>二、 課堂「描述-詮釋-反思」三階層 SLC 課例分析</a:t>
             </a:r>
           </a:p>
@@ -3599,6 +3608,7 @@
               </a:defRPr>
             </a:pPr>
             <a:r>
+              <a:rPr sz="3200"/>
               <a:t>1. 觀察與描述 (Description) (I)</a:t>
             </a:r>
           </a:p>
@@ -3639,6 +3649,7 @@
               </a:defRPr>
             </a:pPr>
             <a:r>
+              <a:rPr sz="2400"/>
               <a:t>• 【觀課細節 1：情境復習與經驗連結】</a:t>
             </a:r>
           </a:p>
@@ -3655,6 +3666,7 @@
               </a:defRPr>
             </a:pPr>
             <a:r>
+              <a:rPr sz="2400"/>
               <a:t>• 教師首先複習課本第 204 頁不同人生階段的理財目標（11歲小學生買單車、17歲高中生買電腦、28歲上班族出國遊學、30歲公務員買汽車、45歲老闆退休環遊世界）。教師詢問：「還記得學到什麼的請舉手？」，引導學生連結前概念。</a:t>
             </a:r>
           </a:p>
@@ -3671,6 +3683,7 @@
               </a:defRPr>
             </a:pPr>
             <a:r>
+              <a:rPr sz="2400"/>
               <a:t>• 【觀課細節 2：收支數學關係與邏輯辯證】</a:t>
             </a:r>
           </a:p>
@@ -3687,6 +3700,7 @@
               </a:defRPr>
             </a:pPr>
             <a:r>
+              <a:rPr sz="2400"/>
               <a:t>• 教師引導學生討論「收入 &gt; 支出」與「支出 &gt; 收入」的結果。學生指出「收入大於支出表示有儲蓄，可以存更多錢；支出大於收入則無法實現目標」。</a:t>
             </a:r>
           </a:p>
@@ -3703,6 +3717,7 @@
               </a:defRPr>
             </a:pPr>
             <a:r>
+              <a:rPr sz="2400"/>
               <a:t>• 【觀課細節 3：小組對話「儲蓄方案大比拼」】</a:t>
             </a:r>
           </a:p>
@@ -3765,6 +3780,7 @@
               </a:defRPr>
             </a:pPr>
             <a:r>
+              <a:rPr sz="3200"/>
               <a:t>1. 觀察與描述 (Description) (II)</a:t>
             </a:r>
           </a:p>
@@ -3805,6 +3821,7 @@
               </a:defRPr>
             </a:pPr>
             <a:r>
+              <a:rPr sz="2400"/>
               <a:t>• 教師發下基本提醒任務，比較兩個方案：</a:t>
             </a:r>
           </a:p>
@@ -3821,6 +3838,7 @@
               </a:defRPr>
             </a:pPr>
             <a:r>
+              <a:rPr sz="2400"/>
               <a:t>• 方案一：先消費，有剩餘再存。</a:t>
             </a:r>
           </a:p>
@@ -3837,6 +3855,7 @@
               </a:defRPr>
             </a:pPr>
             <a:r>
+              <a:rPr sz="2400"/>
               <a:t>• 方案二：先存錢，剩餘再消費。</a:t>
             </a:r>
           </a:p>
@@ -3853,6 +3872,7 @@
               </a:defRPr>
             </a:pPr>
             <a:r>
+              <a:rPr sz="2400"/>
               <a:t>• 教師交代：「三人一組，從第二位同學開始輪流分享理由」，小組內展開對話。</a:t>
             </a:r>
           </a:p>
@@ -3869,7 +3889,8 @@
               </a:defRPr>
             </a:pPr>
             <a:r>
-              <a:t>• 【觀課細節 4：全班凝聚與決策傾向】</a:t>
+              <a:rPr sz="2400"/>
+              <a:t>• 【觀課細節：全班凝聚與決策傾向】</a:t>
             </a:r>
           </a:p>
           <a:p>
@@ -3885,6 +3906,7 @@
               </a:defRPr>
             </a:pPr>
             <a:r>
+              <a:rPr sz="2400"/>
               <a:t>• 小組討論後，全班進行表決與發表。結果全班一致選擇「方案二（先存錢再消費）」，學生紛紛舉手分享選擇方案二能確保目標實現的理由。</a:t>
             </a:r>
           </a:p>
@@ -3947,6 +3969,7 @@
               </a:defRPr>
             </a:pPr>
             <a:r>
+              <a:rPr sz="3200"/>
               <a:t>2. 詮釋與解讀 (Interpretation)</a:t>
             </a:r>
           </a:p>
@@ -3987,6 +4010,7 @@
               </a:defRPr>
             </a:pPr>
             <a:r>
+              <a:rPr sz="2400"/>
               <a:t>• 【學習者認知進程】</a:t>
             </a:r>
           </a:p>
@@ -4003,7 +4027,8 @@
               </a:defRPr>
             </a:pPr>
             <a:r>
-              <a:t>• 學生從小學生的真實生活經驗出發，將抽象的「收支平衡」轉化為具體的「理理財目標實現度」。從最初的單純消費慾望，提升到對「延遲享樂（Deferred Gratification）」與「預算約束」的理解。</a:t>
+              <a:rPr sz="2400"/>
+              <a:t>• 學生從小學生的真實生活經驗出發，將抽象的「收支平衡」轉化為具體的「理財目標實現度」。從最初的單純消費慾望，提升到對「延遲享樂（Deferred Gratification）」與「預算約束」的理解。</a:t>
             </a:r>
           </a:p>
           <a:p>
@@ -4019,6 +4044,7 @@
               </a:defRPr>
             </a:pPr>
             <a:r>
+              <a:rPr sz="2400"/>
               <a:t>• 【小組傾聽與對話品質】</a:t>
             </a:r>
           </a:p>
@@ -4035,6 +4061,7 @@
               </a:defRPr>
             </a:pPr>
             <a:r>
+              <a:rPr sz="2400"/>
               <a:t>• 教師設計「由第二位同學開始輪流發言」的結構化對話機制，確保了小組內每一位成員都有發言與被傾聽的機會。異質小組中，較熟練的學生帶動思考，協助同儕理解「預防不時之需」與「目標導向儲蓄」的優勢。</a:t>
             </a:r>
           </a:p>
@@ -4097,6 +4124,7 @@
               </a:defRPr>
             </a:pPr>
             <a:r>
+              <a:rPr sz="3200"/>
               <a:t>3. 反思與教學建議 (Reflection) (I)</a:t>
             </a:r>
           </a:p>
@@ -4137,6 +4165,7 @@
               </a:defRPr>
             </a:pPr>
             <a:r>
+              <a:rPr sz="2400"/>
               <a:t>• 【亮點與效益】</a:t>
             </a:r>
           </a:p>
@@ -4153,6 +4182,7 @@
               </a:defRPr>
             </a:pPr>
             <a:r>
+              <a:rPr sz="2400"/>
               <a:t>• 真實情境與人生階梯：結合不同年齡層的理財目標，讓學生深刻感受理財是貫穿一生的重要能力。</a:t>
             </a:r>
           </a:p>
@@ -4169,7 +4199,8 @@
               </a:defRPr>
             </a:pPr>
             <a:r>
-              <a:t>• 2. 對話結構清晰：透過 SLC 相互傾聽機制，讓社會科的價值判斷題目（消費 vs 儲蓄）變成真實對話而非死記硬背。</a:t>
+              <a:rPr sz="2400"/>
+              <a:t>• 對話結構清晰：透過 SLC 相互傾聽機制，讓社會科的價值判斷題目（消費 vs 儲蓄）變成真實對話而非死記硬背。</a:t>
             </a:r>
           </a:p>
         </p:txBody>
@@ -4231,6 +4262,7 @@
               </a:defRPr>
             </a:pPr>
             <a:r>
+              <a:rPr sz="3200"/>
               <a:t>3. 反思與教學建議 (Reflection) (II)</a:t>
             </a:r>
           </a:p>
@@ -4271,6 +4303,7 @@
               </a:defRPr>
             </a:pPr>
             <a:r>
+              <a:rPr sz="2400"/>
               <a:t>• 【進一步探究之延伸建議 (伸展跳躍)】</a:t>
             </a:r>
           </a:p>
@@ -4287,6 +4320,7 @@
               </a:defRPr>
             </a:pPr>
             <a:r>
+              <a:rPr sz="2400"/>
               <a:t>• 可增加「意外支出情境題」（例如：電腦忽然壞掉需要維修），引導學生思考應變資金（緊急預備金）的重要性，實現更高層次的認知跳躍。</a:t>
             </a:r>
           </a:p>
@@ -4303,6 +4337,7 @@
               </a:defRPr>
             </a:pPr>
             <a:r>
+              <a:rPr sz="2400"/>
               <a:t>• </a:t>
             </a:r>
           </a:p>

</xml_diff>

<commit_message>
fix: purge trailing empty bullet points from slide 3 and slide 9
</commit_message>
<xml_diff>
--- a/output/slides.pptx
+++ b/output/slides.pptx
@@ -3161,7 +3161,6 @@
             <a:spAutoFit/>
           </a:bodyPr>
           <a:lstStyle/>
-          <a:p/>
         </p:txBody>
       </p:sp>
       <p:pic>
@@ -3272,7 +3271,6 @@
             <a:spAutoFit/>
           </a:bodyPr>
           <a:lstStyle/>
-          <a:p/>
           <a:p>
             <a:pPr>
               <a:spcAft>
@@ -3410,7 +3408,6 @@
             <a:spAutoFit/>
           </a:bodyPr>
           <a:lstStyle/>
-          <a:p/>
           <a:p>
             <a:pPr>
               <a:spcAft>
@@ -3443,23 +3440,6 @@
             <a:r>
               <a:rPr sz="2400"/>
               <a:t>• 小組學習機制：3-4人異質小組、對話協同學習、舉手發表與全班互學。</a:t>
-            </a:r>
-          </a:p>
-          <a:p>
-            <a:pPr>
-              <a:spcAft>
-                <a:spcPts val="1000"/>
-              </a:spcAft>
-              <a:defRPr sz="2400">
-                <a:solidFill>
-                  <a:srgbClr val="1E3250"/>
-                </a:solidFill>
-                <a:latin typeface="Microsoft JhengHei"/>
-              </a:defRPr>
-            </a:pPr>
-            <a:r>
-              <a:rPr sz="2400"/>
-              <a:t>• </a:t>
             </a:r>
           </a:p>
         </p:txBody>
@@ -3548,7 +3528,6 @@
             <a:spAutoFit/>
           </a:bodyPr>
           <a:lstStyle/>
-          <a:p/>
         </p:txBody>
       </p:sp>
     </p:spTree>
@@ -3635,7 +3614,6 @@
             <a:spAutoFit/>
           </a:bodyPr>
           <a:lstStyle/>
-          <a:p/>
           <a:p>
             <a:pPr>
               <a:spcAft>
@@ -3807,7 +3785,6 @@
             <a:spAutoFit/>
           </a:bodyPr>
           <a:lstStyle/>
-          <a:p/>
           <a:p>
             <a:pPr>
               <a:spcAft>
@@ -3996,7 +3973,6 @@
             <a:spAutoFit/>
           </a:bodyPr>
           <a:lstStyle/>
-          <a:p/>
           <a:p>
             <a:pPr>
               <a:spcAft>
@@ -4151,7 +4127,6 @@
             <a:spAutoFit/>
           </a:bodyPr>
           <a:lstStyle/>
-          <a:p/>
           <a:p>
             <a:pPr>
               <a:spcAft>
@@ -4289,7 +4264,6 @@
             <a:spAutoFit/>
           </a:bodyPr>
           <a:lstStyle/>
-          <a:p/>
           <a:p>
             <a:pPr>
               <a:spcAft>
@@ -4322,23 +4296,6 @@
             <a:r>
               <a:rPr sz="2400"/>
               <a:t>• 可增加「意外支出情境題」（例如：電腦忽然壞掉需要維修），引導學生思考應變資金（緊急預備金）的重要性，實現更高層次的認知跳躍。</a:t>
-            </a:r>
-          </a:p>
-          <a:p>
-            <a:pPr>
-              <a:spcAft>
-                <a:spcPts val="1000"/>
-              </a:spcAft>
-              <a:defRPr sz="2400">
-                <a:solidFill>
-                  <a:srgbClr val="1E3250"/>
-                </a:solidFill>
-                <a:latin typeface="Microsoft JhengHei"/>
-              </a:defRPr>
-            </a:pPr>
-            <a:r>
-              <a:rPr sz="2400"/>
-              <a:t>• </a:t>
             </a:r>
           </a:p>
         </p:txBody>

</xml_diff>